<commit_message>
Fix M06 Slide 3: shorten recovery model cards, clear footer
</commit_message>
<xml_diff>
--- a/contents/Module-06-Backup-and-Restore.pptx
+++ b/contents/Module-06-Backup-and-Restore.pptx
@@ -4381,7 +4381,7 @@
         <p:spPr>
           <a:xfrm>
             <a:off x="411480" y="1463040"/>
-            <a:ext cx="3639312" cy="4434840"/>
+            <a:ext cx="3639312" cy="4114800"/>
           </a:xfrm>
           <a:prstGeom prst="rect">
             <a:avLst/>
@@ -4459,7 +4459,7 @@
         <p:spPr>
           <a:xfrm>
             <a:off x="594360" y="2121408"/>
-            <a:ext cx="3291840" cy="3474720"/>
+            <a:ext cx="3291840" cy="3154680"/>
           </a:xfrm>
           <a:prstGeom prst="rect">
             <a:avLst/>
@@ -4497,7 +4497,7 @@
         <p:spPr>
           <a:xfrm>
             <a:off x="4325112" y="1463040"/>
-            <a:ext cx="3639312" cy="4434840"/>
+            <a:ext cx="3639312" cy="4114800"/>
           </a:xfrm>
           <a:prstGeom prst="rect">
             <a:avLst/>
@@ -4575,7 +4575,7 @@
         <p:spPr>
           <a:xfrm>
             <a:off x="4507992" y="2121408"/>
-            <a:ext cx="3291840" cy="3474720"/>
+            <a:ext cx="3291840" cy="3154680"/>
           </a:xfrm>
           <a:prstGeom prst="rect">
             <a:avLst/>
@@ -4613,7 +4613,7 @@
         <p:spPr>
           <a:xfrm>
             <a:off x="8238744" y="1463040"/>
-            <a:ext cx="3639312" cy="4434840"/>
+            <a:ext cx="3639312" cy="4114800"/>
           </a:xfrm>
           <a:prstGeom prst="rect">
             <a:avLst/>
@@ -4691,7 +4691,7 @@
         <p:spPr>
           <a:xfrm>
             <a:off x="8421624" y="2121408"/>
-            <a:ext cx="3291840" cy="3474720"/>
+            <a:ext cx="3291840" cy="3154680"/>
           </a:xfrm>
           <a:prstGeom prst="rect">
             <a:avLst/>
@@ -4728,7 +4728,7 @@
         </p:nvSpPr>
         <p:spPr>
           <a:xfrm>
-            <a:off x="411480" y="5961888"/>
+            <a:off x="411480" y="5687568"/>
             <a:ext cx="7315200" cy="566928"/>
           </a:xfrm>
           <a:prstGeom prst="rect">
@@ -4771,7 +4771,7 @@
         </p:nvSpPr>
         <p:spPr>
           <a:xfrm>
-            <a:off x="576072" y="6071616"/>
+            <a:off x="576072" y="5797296"/>
             <a:ext cx="6986016" cy="347472"/>
           </a:xfrm>
           <a:prstGeom prst="rect">
@@ -4805,7 +4805,7 @@
         </p:nvSpPr>
         <p:spPr>
           <a:xfrm>
-            <a:off x="7863840" y="6035040"/>
+            <a:off x="7863840" y="5742432"/>
             <a:ext cx="3931920" cy="384048"/>
           </a:xfrm>
           <a:prstGeom prst="rect">
@@ -5395,7 +5395,7 @@
         </p:nvSpPr>
         <p:spPr>
           <a:xfrm>
-            <a:off x="411480" y="6446520"/>
+            <a:off x="411480" y="6035040"/>
             <a:ext cx="11384280" cy="274320"/>
           </a:xfrm>
           <a:prstGeom prst="rect">
@@ -7978,7 +7978,7 @@
         <p:spPr>
           <a:xfrm>
             <a:off x="640080" y="2852928"/>
-            <a:ext cx="292608" cy="292608"/>
+            <a:ext cx="384048" cy="292608"/>
           </a:xfrm>
           <a:prstGeom prst="rect">
             <a:avLst/>
@@ -8021,7 +8021,7 @@
         <p:spPr>
           <a:xfrm>
             <a:off x="640080" y="2871216"/>
-            <a:ext cx="292608" cy="256032"/>
+            <a:ext cx="384048" cy="256032"/>
           </a:xfrm>
           <a:prstGeom prst="rect">
             <a:avLst/>
@@ -8055,8 +8055,8 @@
         </p:nvSpPr>
         <p:spPr>
           <a:xfrm>
-            <a:off x="1051560" y="2834640"/>
-            <a:ext cx="6217920" cy="320040"/>
+            <a:off x="1115568" y="2834640"/>
+            <a:ext cx="6153912" cy="292608"/>
           </a:xfrm>
           <a:prstGeom prst="rect">
             <a:avLst/>
@@ -8090,8 +8090,8 @@
         </p:nvSpPr>
         <p:spPr>
           <a:xfrm>
-            <a:off x="640080" y="3236976"/>
-            <a:ext cx="292608" cy="292608"/>
+            <a:off x="640080" y="3200400"/>
+            <a:ext cx="384048" cy="292608"/>
           </a:xfrm>
           <a:prstGeom prst="rect">
             <a:avLst/>
@@ -8133,8 +8133,8 @@
         </p:nvSpPr>
         <p:spPr>
           <a:xfrm>
-            <a:off x="640080" y="3255264"/>
-            <a:ext cx="292608" cy="256032"/>
+            <a:off x="640080" y="3218688"/>
+            <a:ext cx="384048" cy="256032"/>
           </a:xfrm>
           <a:prstGeom prst="rect">
             <a:avLst/>
@@ -8168,8 +8168,8 @@
         </p:nvSpPr>
         <p:spPr>
           <a:xfrm>
-            <a:off x="1051560" y="3218688"/>
-            <a:ext cx="6217920" cy="320040"/>
+            <a:off x="1115568" y="3182112"/>
+            <a:ext cx="6153912" cy="292608"/>
           </a:xfrm>
           <a:prstGeom prst="rect">
             <a:avLst/>
@@ -8203,8 +8203,8 @@
         </p:nvSpPr>
         <p:spPr>
           <a:xfrm>
-            <a:off x="640080" y="3621024"/>
-            <a:ext cx="292608" cy="292608"/>
+            <a:off x="640080" y="3547872"/>
+            <a:ext cx="384048" cy="292608"/>
           </a:xfrm>
           <a:prstGeom prst="rect">
             <a:avLst/>
@@ -8246,8 +8246,8 @@
         </p:nvSpPr>
         <p:spPr>
           <a:xfrm>
-            <a:off x="640080" y="3639312"/>
-            <a:ext cx="292608" cy="256032"/>
+            <a:off x="640080" y="3566160"/>
+            <a:ext cx="384048" cy="256032"/>
           </a:xfrm>
           <a:prstGeom prst="rect">
             <a:avLst/>
@@ -8281,8 +8281,8 @@
         </p:nvSpPr>
         <p:spPr>
           <a:xfrm>
-            <a:off x="1051560" y="3602736"/>
-            <a:ext cx="6217920" cy="320040"/>
+            <a:off x="1115568" y="3529584"/>
+            <a:ext cx="6153912" cy="292608"/>
           </a:xfrm>
           <a:prstGeom prst="rect">
             <a:avLst/>
@@ -8316,8 +8316,8 @@
         </p:nvSpPr>
         <p:spPr>
           <a:xfrm>
-            <a:off x="640080" y="4005072"/>
-            <a:ext cx="292608" cy="292608"/>
+            <a:off x="640080" y="3895344"/>
+            <a:ext cx="384048" cy="292608"/>
           </a:xfrm>
           <a:prstGeom prst="rect">
             <a:avLst/>
@@ -8359,8 +8359,8 @@
         </p:nvSpPr>
         <p:spPr>
           <a:xfrm>
-            <a:off x="640080" y="4023360"/>
-            <a:ext cx="292608" cy="256032"/>
+            <a:off x="640080" y="3913632"/>
+            <a:ext cx="384048" cy="256032"/>
           </a:xfrm>
           <a:prstGeom prst="rect">
             <a:avLst/>
@@ -8394,8 +8394,8 @@
         </p:nvSpPr>
         <p:spPr>
           <a:xfrm>
-            <a:off x="1051560" y="3986784"/>
-            <a:ext cx="6217920" cy="320040"/>
+            <a:off x="1115568" y="3877056"/>
+            <a:ext cx="6153912" cy="292608"/>
           </a:xfrm>
           <a:prstGeom prst="rect">
             <a:avLst/>
@@ -8429,8 +8429,8 @@
         </p:nvSpPr>
         <p:spPr>
           <a:xfrm>
-            <a:off x="640080" y="4389120"/>
-            <a:ext cx="292608" cy="292608"/>
+            <a:off x="640080" y="4242816"/>
+            <a:ext cx="384048" cy="292608"/>
           </a:xfrm>
           <a:prstGeom prst="rect">
             <a:avLst/>
@@ -8472,8 +8472,8 @@
         </p:nvSpPr>
         <p:spPr>
           <a:xfrm>
-            <a:off x="640080" y="4407408"/>
-            <a:ext cx="292608" cy="256032"/>
+            <a:off x="640080" y="4261104"/>
+            <a:ext cx="384048" cy="256032"/>
           </a:xfrm>
           <a:prstGeom prst="rect">
             <a:avLst/>
@@ -8507,8 +8507,8 @@
         </p:nvSpPr>
         <p:spPr>
           <a:xfrm>
-            <a:off x="1051560" y="4370832"/>
-            <a:ext cx="6217920" cy="320040"/>
+            <a:off x="1115568" y="4224528"/>
+            <a:ext cx="6153912" cy="292608"/>
           </a:xfrm>
           <a:prstGeom prst="rect">
             <a:avLst/>
@@ -8542,8 +8542,8 @@
         </p:nvSpPr>
         <p:spPr>
           <a:xfrm>
-            <a:off x="640080" y="4773168"/>
-            <a:ext cx="292608" cy="292608"/>
+            <a:off x="640080" y="4590288"/>
+            <a:ext cx="384048" cy="292608"/>
           </a:xfrm>
           <a:prstGeom prst="rect">
             <a:avLst/>
@@ -8585,8 +8585,8 @@
         </p:nvSpPr>
         <p:spPr>
           <a:xfrm>
-            <a:off x="640080" y="4791456"/>
-            <a:ext cx="292608" cy="256032"/>
+            <a:off x="640080" y="4608576"/>
+            <a:ext cx="384048" cy="256032"/>
           </a:xfrm>
           <a:prstGeom prst="rect">
             <a:avLst/>
@@ -8620,8 +8620,8 @@
         </p:nvSpPr>
         <p:spPr>
           <a:xfrm>
-            <a:off x="1051560" y="4754880"/>
-            <a:ext cx="6217920" cy="320040"/>
+            <a:off x="1115568" y="4572000"/>
+            <a:ext cx="6153912" cy="292608"/>
           </a:xfrm>
           <a:prstGeom prst="rect">
             <a:avLst/>
@@ -8655,8 +8655,8 @@
         </p:nvSpPr>
         <p:spPr>
           <a:xfrm>
-            <a:off x="640080" y="5157216"/>
-            <a:ext cx="292608" cy="292608"/>
+            <a:off x="640080" y="4937760"/>
+            <a:ext cx="384048" cy="292608"/>
           </a:xfrm>
           <a:prstGeom prst="rect">
             <a:avLst/>
@@ -8698,8 +8698,8 @@
         </p:nvSpPr>
         <p:spPr>
           <a:xfrm>
-            <a:off x="640080" y="5175504"/>
-            <a:ext cx="292608" cy="256032"/>
+            <a:off x="640080" y="4956048"/>
+            <a:ext cx="384048" cy="256032"/>
           </a:xfrm>
           <a:prstGeom prst="rect">
             <a:avLst/>
@@ -8733,8 +8733,8 @@
         </p:nvSpPr>
         <p:spPr>
           <a:xfrm>
-            <a:off x="1051560" y="5138928"/>
-            <a:ext cx="6217920" cy="320040"/>
+            <a:off x="1115568" y="4919472"/>
+            <a:ext cx="6153912" cy="292608"/>
           </a:xfrm>
           <a:prstGeom prst="rect">
             <a:avLst/>
@@ -8768,8 +8768,8 @@
         </p:nvSpPr>
         <p:spPr>
           <a:xfrm>
-            <a:off x="640080" y="5541264"/>
-            <a:ext cx="292608" cy="292608"/>
+            <a:off x="640080" y="5285232"/>
+            <a:ext cx="384048" cy="292608"/>
           </a:xfrm>
           <a:prstGeom prst="rect">
             <a:avLst/>
@@ -8811,8 +8811,8 @@
         </p:nvSpPr>
         <p:spPr>
           <a:xfrm>
-            <a:off x="640080" y="5559552"/>
-            <a:ext cx="292608" cy="256032"/>
+            <a:off x="640080" y="5303520"/>
+            <a:ext cx="384048" cy="256032"/>
           </a:xfrm>
           <a:prstGeom prst="rect">
             <a:avLst/>
@@ -8846,8 +8846,8 @@
         </p:nvSpPr>
         <p:spPr>
           <a:xfrm>
-            <a:off x="1051560" y="5522976"/>
-            <a:ext cx="6217920" cy="320040"/>
+            <a:off x="1115568" y="5266944"/>
+            <a:ext cx="6153912" cy="292608"/>
           </a:xfrm>
           <a:prstGeom prst="rect">
             <a:avLst/>
@@ -8881,8 +8881,8 @@
         </p:nvSpPr>
         <p:spPr>
           <a:xfrm>
-            <a:off x="640080" y="5925312"/>
-            <a:ext cx="292608" cy="292608"/>
+            <a:off x="640080" y="5632704"/>
+            <a:ext cx="384048" cy="292608"/>
           </a:xfrm>
           <a:prstGeom prst="rect">
             <a:avLst/>
@@ -8924,8 +8924,8 @@
         </p:nvSpPr>
         <p:spPr>
           <a:xfrm>
-            <a:off x="640080" y="5943600"/>
-            <a:ext cx="292608" cy="256032"/>
+            <a:off x="640080" y="5650992"/>
+            <a:ext cx="384048" cy="256032"/>
           </a:xfrm>
           <a:prstGeom prst="rect">
             <a:avLst/>
@@ -8959,8 +8959,8 @@
         </p:nvSpPr>
         <p:spPr>
           <a:xfrm>
-            <a:off x="1051560" y="5907024"/>
-            <a:ext cx="6217920" cy="320040"/>
+            <a:off x="1115568" y="5614416"/>
+            <a:ext cx="6153912" cy="292608"/>
           </a:xfrm>
           <a:prstGeom prst="rect">
             <a:avLst/>
@@ -8994,8 +8994,8 @@
         </p:nvSpPr>
         <p:spPr>
           <a:xfrm>
-            <a:off x="640080" y="6309360"/>
-            <a:ext cx="292608" cy="292608"/>
+            <a:off x="640080" y="5980176"/>
+            <a:ext cx="384048" cy="292608"/>
           </a:xfrm>
           <a:prstGeom prst="rect">
             <a:avLst/>
@@ -9037,8 +9037,8 @@
         </p:nvSpPr>
         <p:spPr>
           <a:xfrm>
-            <a:off x="640080" y="6327648"/>
-            <a:ext cx="292608" cy="256032"/>
+            <a:off x="640080" y="5998464"/>
+            <a:ext cx="384048" cy="256032"/>
           </a:xfrm>
           <a:prstGeom prst="rect">
             <a:avLst/>
@@ -9072,8 +9072,8 @@
         </p:nvSpPr>
         <p:spPr>
           <a:xfrm>
-            <a:off x="1051560" y="6291072"/>
-            <a:ext cx="6217920" cy="320040"/>
+            <a:off x="1115568" y="5961888"/>
+            <a:ext cx="6153912" cy="292608"/>
           </a:xfrm>
           <a:prstGeom prst="rect">
             <a:avLst/>

</xml_diff>